<commit_message>
Update manager and service advisor training decks
</commit_message>
<xml_diff>
--- a/public/files/training/store-manager-01-operational-standardization.pptx
+++ b/public/files/training/store-manager-01-operational-standardization.pptx
@@ -11253,7 +11253,7 @@
                 <a:ea typeface="微软雅黑" panose="020B0503020204020204" charset="-122"/>
                 <a:cs typeface="微软雅黑" panose="020B0503020204020204" charset="-122"/>
               </a:rPr>
-              <a:t>ServAuto 自营店店长工作内容讲解</a:t>
+              <a:t>ServAuto 店店长工作内容讲解</a:t>
             </a:r>
             <a:endParaRPr lang="en-US" sz="4000" b="1">
               <a:latin typeface="Arial" panose="020B0604020202020204"/>
@@ -14115,7 +14115,51 @@
                 <a:ea typeface="微软雅黑" panose="020B0503020204020204" charset="-122"/>
                 <a:cs typeface="微软雅黑" panose="020B0503020204020204" charset="-122"/>
               </a:rPr>
-              <a:t>话术、检测项目、施工节点、交车检查、回访规则，一岗一册。</a:t>
+              <a:t>话术、检测项目、施工节点、交车检查、回访规则</a:t>
+            </a:r>
+            <a:r>
+              <a:rPr lang="zh-CN" altLang="en-US" sz="1000" b="0">
+                <a:solidFill>
+                  <a:srgbClr val="1F2329"/>
+                </a:solidFill>
+                <a:latin typeface="微软雅黑" panose="020B0503020204020204" charset="-122"/>
+                <a:ea typeface="微软雅黑" panose="020B0503020204020204" charset="-122"/>
+                <a:cs typeface="微软雅黑" panose="020B0503020204020204" charset="-122"/>
+              </a:rPr>
+              <a:t>（跟随</a:t>
+            </a:r>
+            <a:r>
+              <a:rPr lang="en-US" altLang="zh-CN" sz="1000" b="0">
+                <a:solidFill>
+                  <a:srgbClr val="1F2329"/>
+                </a:solidFill>
+                <a:latin typeface="微软雅黑" panose="020B0503020204020204" charset="-122"/>
+                <a:ea typeface="微软雅黑" panose="020B0503020204020204" charset="-122"/>
+                <a:cs typeface="微软雅黑" panose="020B0503020204020204" charset="-122"/>
+              </a:rPr>
+              <a:t>sop</a:t>
+            </a:r>
+            <a:r>
+              <a:rPr lang="zh-CN" altLang="en-US" sz="1000" b="0">
+                <a:solidFill>
+                  <a:srgbClr val="1F2329"/>
+                </a:solidFill>
+                <a:latin typeface="微软雅黑" panose="020B0503020204020204" charset="-122"/>
+                <a:ea typeface="微软雅黑" panose="020B0503020204020204" charset="-122"/>
+                <a:cs typeface="微软雅黑" panose="020B0503020204020204" charset="-122"/>
+              </a:rPr>
+              <a:t>）</a:t>
+            </a:r>
+            <a:r>
+              <a:rPr lang="en-US" altLang="en-US" sz="1000" b="0">
+                <a:solidFill>
+                  <a:srgbClr val="1F2329"/>
+                </a:solidFill>
+                <a:latin typeface="微软雅黑" panose="020B0503020204020204" charset="-122"/>
+                <a:ea typeface="微软雅黑" panose="020B0503020204020204" charset="-122"/>
+                <a:cs typeface="微软雅黑" panose="020B0503020204020204" charset="-122"/>
+              </a:rPr>
+              <a:t>。</a:t>
             </a:r>
             <a:endParaRPr lang="en-US" altLang="en-US" sz="1350">
               <a:solidFill>
@@ -14149,7 +14193,29 @@
                 <a:ea typeface="微软雅黑" panose="020B0503020204020204" charset="-122"/>
                 <a:cs typeface="微软雅黑" panose="020B0503020204020204" charset="-122"/>
               </a:rPr>
-              <a:t>Scripts, inspection items, service checkpoints, handover checks, follow-up rules.</a:t>
+              <a:t>Scripts, inspection items, service checkpoints, handover checks, follow-up </a:t>
+            </a:r>
+            <a:r>
+              <a:rPr lang="en-US" altLang="zh-CN" sz="850" b="0">
+                <a:solidFill>
+                  <a:srgbClr val="6E8299"/>
+                </a:solidFill>
+                <a:latin typeface="微软雅黑" panose="020B0503020204020204" charset="-122"/>
+                <a:ea typeface="微软雅黑" panose="020B0503020204020204" charset="-122"/>
+                <a:cs typeface="微软雅黑" panose="020B0503020204020204" charset="-122"/>
+              </a:rPr>
+              <a:t>sop</a:t>
+            </a:r>
+            <a:r>
+              <a:rPr lang="zh-CN" altLang="en-US" sz="850" b="0">
+                <a:solidFill>
+                  <a:srgbClr val="6E8299"/>
+                </a:solidFill>
+                <a:latin typeface="微软雅黑" panose="020B0503020204020204" charset="-122"/>
+                <a:ea typeface="微软雅黑" panose="020B0503020204020204" charset="-122"/>
+                <a:cs typeface="微软雅黑" panose="020B0503020204020204" charset="-122"/>
+              </a:rPr>
+              <a:t>.</a:t>
             </a:r>
             <a:endParaRPr lang="zh-CN" altLang="en-US" sz="950">
               <a:solidFill>
@@ -19730,7 +19796,7 @@
         <p:spPr>
           <a:xfrm>
             <a:off x="612648" y="603504"/>
-            <a:ext cx="10972800" cy="457200"/>
+            <a:ext cx="10972800" cy="400050"/>
           </a:xfrm>
           <a:prstGeom prst="rect">
             <a:avLst/>
@@ -19744,6 +19810,17 @@
           <a:lstStyle/>
           <a:p>
             <a:pPr algn="l"/>
+            <a:r>
+              <a:rPr lang="en-US" sz="2600" b="1">
+                <a:solidFill>
+                  <a:srgbClr val="0B1D35"/>
+                </a:solidFill>
+                <a:latin typeface="微软雅黑" panose="020B0503020204020204" charset="-122"/>
+                <a:ea typeface="微软雅黑" panose="020B0503020204020204" charset="-122"/>
+                <a:cs typeface="微软雅黑" panose="020B0503020204020204" charset="-122"/>
+              </a:rPr>
+              <a:t>Must </a:t>
+            </a:r>
             <a:r>
               <a:rPr sz="2600" b="1">
                 <a:solidFill>
@@ -19753,7 +19830,7 @@
                 <a:ea typeface="微软雅黑" panose="020B0503020204020204" charset="-122"/>
                 <a:cs typeface="微软雅黑" panose="020B0503020204020204" charset="-122"/>
               </a:rPr>
-              <a:t>Six Touchpoints: Who Does What, and by When</a:t>
+              <a:t>Touchpoints: Who Does What, and by When</a:t>
             </a:r>
             <a:endParaRPr sz="2600" b="1">
               <a:solidFill>
@@ -19775,7 +19852,7 @@
         <p:spPr>
           <a:xfrm>
             <a:off x="612648" y="1088136"/>
-            <a:ext cx="10972800" cy="292608"/>
+            <a:ext cx="10972800" cy="276860"/>
           </a:xfrm>
           <a:prstGeom prst="rect">
             <a:avLst/>
@@ -19798,7 +19875,29 @@
                 <a:ea typeface="微软雅黑" panose="020B0503020204020204" charset="-122"/>
                 <a:cs typeface="微软雅黑" panose="020B0503020204020204" charset="-122"/>
               </a:rPr>
-              <a:t>客户体验六环节：谁做、多久做完</a:t>
+              <a:t>客户体验</a:t>
+            </a:r>
+            <a:r>
+              <a:rPr lang="zh-CN" sz="1800" b="0">
+                <a:solidFill>
+                  <a:srgbClr val="6E8299"/>
+                </a:solidFill>
+                <a:latin typeface="微软雅黑" panose="020B0503020204020204" charset="-122"/>
+                <a:ea typeface="微软雅黑" panose="020B0503020204020204" charset="-122"/>
+                <a:cs typeface="微软雅黑" panose="020B0503020204020204" charset="-122"/>
+              </a:rPr>
+              <a:t>必须环节</a:t>
+            </a:r>
+            <a:r>
+              <a:rPr sz="1800" b="0">
+                <a:solidFill>
+                  <a:srgbClr val="6E8299"/>
+                </a:solidFill>
+                <a:latin typeface="微软雅黑" panose="020B0503020204020204" charset="-122"/>
+                <a:ea typeface="微软雅黑" panose="020B0503020204020204" charset="-122"/>
+                <a:cs typeface="微软雅黑" panose="020B0503020204020204" charset="-122"/>
+              </a:rPr>
+              <a:t>：谁做、多久做完</a:t>
             </a:r>
             <a:endParaRPr sz="1800" b="0">
               <a:solidFill>
@@ -22268,15 +22367,43 @@
               </a:spcAft>
             </a:pPr>
             <a:r>
-              <a:rPr lang="en-US" altLang="en-US" sz="1050" b="0" kern="0">
+              <a:rPr lang="zh-CN" altLang="en-US" sz="1200" kern="0">
                 <a:solidFill>
-                  <a:srgbClr val="1F2329"/>
+                  <a:schemeClr val="tx1">
+                    <a:lumMod val="85000"/>
+                    <a:lumOff val="15000"/>
+                  </a:schemeClr>
                 </a:solidFill>
-                <a:latin typeface="微软雅黑" panose="020B0503020204020204" charset="-122"/>
+                <a:latin typeface="Arial" panose="020B0604020202020204"/>
                 <a:ea typeface="微软雅黑" panose="020B0503020204020204" charset="-122"/>
-                <a:cs typeface="微软雅黑" panose="020B0503020204020204" charset="-122"/>
               </a:rPr>
-              <a:t>把六环节标准写成一岗一册，张贴到对应工位。</a:t>
+              <a:t>各岗位执行</a:t>
+            </a:r>
+            <a:r>
+              <a:rPr lang="en-US" altLang="zh-CN" sz="1200" kern="0">
+                <a:solidFill>
+                  <a:schemeClr val="tx1">
+                    <a:lumMod val="85000"/>
+                    <a:lumOff val="15000"/>
+                  </a:schemeClr>
+                </a:solidFill>
+                <a:latin typeface="Arial" panose="020B0604020202020204"/>
+                <a:ea typeface="微软雅黑" panose="020B0503020204020204" charset="-122"/>
+              </a:rPr>
+              <a:t>sop</a:t>
+            </a:r>
+            <a:r>
+              <a:rPr lang="zh-CN" altLang="en-US" sz="1200" kern="0">
+                <a:solidFill>
+                  <a:schemeClr val="tx1">
+                    <a:lumMod val="85000"/>
+                    <a:lumOff val="15000"/>
+                  </a:schemeClr>
+                </a:solidFill>
+                <a:latin typeface="Arial" panose="020B0604020202020204"/>
+                <a:ea typeface="微软雅黑" panose="020B0503020204020204" charset="-122"/>
+              </a:rPr>
+              <a:t>跟话术</a:t>
             </a:r>
             <a:endParaRPr lang="en-US" altLang="en-US" sz="1200" kern="0">
               <a:solidFill>
@@ -22302,22 +22429,27 @@
               </a:spcAft>
             </a:pPr>
             <a:r>
-              <a:rPr lang="zh-CN" altLang="en-US" sz="850" b="0" kern="0">
+              <a:rPr lang="en-US" altLang="zh-CN" sz="1200" kern="0">
                 <a:solidFill>
-                  <a:srgbClr val="6E8299"/>
+                  <a:schemeClr val="tx1">
+                    <a:lumMod val="85000"/>
+                    <a:lumOff val="15000"/>
+                  </a:schemeClr>
                 </a:solidFill>
-                <a:latin typeface="微软雅黑" panose="020B0503020204020204" charset="-122"/>
+                <a:latin typeface="Arial" panose="020B0604020202020204"/>
                 <a:ea typeface="微软雅黑" panose="020B0503020204020204" charset="-122"/>
-                <a:cs typeface="微软雅黑" panose="020B0503020204020204" charset="-122"/>
               </a:rPr>
-              <a:t>Write the six-step standards into one booklet per role and post them at each workstation.</a:t>
-            </a:r>
-            <a:endParaRPr lang="zh-CN" altLang="en-US" sz="850" kern="0">
+              <a:t>SOP &amp; Talk Tracks for Each Position</a:t>
+            </a:r>
+            <a:endParaRPr lang="en-US" altLang="zh-CN" sz="1200" kern="0">
               <a:solidFill>
-                <a:srgbClr val="6E8299"/>
+                <a:schemeClr val="tx1">
+                  <a:lumMod val="85000"/>
+                  <a:lumOff val="15000"/>
+                </a:schemeClr>
               </a:solidFill>
-              <a:latin typeface="+mn-ea"/>
-              <a:cs typeface="+mn-ea"/>
+              <a:latin typeface="Arial" panose="020B0604020202020204"/>
+              <a:ea typeface="微软雅黑" panose="020B0503020204020204" charset="-122"/>
             </a:endParaRPr>
           </a:p>
         </p:txBody>

</xml_diff>